<commit_message>
deck: real-model figures on slides 5, 7 and 8
Slide 7 tiles: the stub's -1.04 s median TTFT is replaced by the real-model
figure where the effect survives (-3.17 s on two-question calls,
gemini-3.5-flash-lite), and '0 fabricated citations' by 158/158 claims
backed by their cited passage. Slide 8: the keyless table stays, labelled
as keyless; a real-model card replaces the ablation card; limitations now
state the real-model latency, tail and coverage results instead of
'groundedness needs a model run'. Slide 5: the demo beat no longer quotes
a stub latency.

Co-Authored-By: Claude Opus 5.5 <noreply@anthropic.com>
Claude-Session: https://claude.ai/code/session_01MzXC4pm3GCFREaMG4Dd7sK
</commit_message>
<xml_diff>
--- a/VITVellore_Ripple_Submission.pptx
+++ b/VITVellore_Ripple_Submission.pptx
@@ -18006,7 +18006,7 @@
                 </a:solidFill>
                 <a:latin typeface="Arial"/>
               </a:rPr>
-              <a:t>First token at −1.04 s</a:t>
+              <a:t>Answer starts before they finish</a:t>
             </a:r>
           </a:p>
         </p:txBody>
@@ -19532,7 +19532,7 @@
                 </a:solidFill>
                 <a:latin typeface="Arial"/>
               </a:rPr>
-              <a:t>−1.04 s</a:t>
+              <a:t>−3.17 s</a:t>
             </a:r>
           </a:p>
           <a:p>
@@ -19551,7 +19551,7 @@
                 </a:solidFill>
                 <a:latin typeface="Calibri"/>
               </a:rPr>
-              <a:t>median time to first token</a:t>
+              <a:t>first answer, two-question calls</a:t>
             </a:r>
           </a:p>
           <a:p>
@@ -19570,7 +19570,7 @@
                 </a:solidFill>
                 <a:latin typeface="Calibri"/>
               </a:rPr>
-              <a:t>relative to end of utterance</a:t>
+              <a:t>before the customer finishes · real model</a:t>
             </a:r>
           </a:p>
         </p:txBody>
@@ -19832,7 +19832,7 @@
                 </a:solidFill>
                 <a:latin typeface="Arial"/>
               </a:rPr>
-              <a:t>0</a:t>
+              <a:t>158/158</a:t>
             </a:r>
           </a:p>
           <a:p>
@@ -19851,7 +19851,7 @@
                 </a:solidFill>
                 <a:latin typeface="Calibri"/>
               </a:rPr>
-              <a:t>fabricated citations</a:t>
+              <a:t>claims backed by the cited passage</a:t>
             </a:r>
           </a:p>
           <a:p>
@@ -19870,7 +19870,7 @@
                 </a:solidFill>
                 <a:latin typeface="Calibri"/>
               </a:rPr>
-              <a:t>of 159 issued</a:t>
+              <a:t>gemini-3.5-flash-lite · 0 fabricated</a:t>
             </a:r>
           </a:p>
         </p:txBody>
@@ -20318,7 +20318,7 @@
                 </a:solidFill>
                 <a:latin typeface="Calibri"/>
               </a:rPr>
-              <a:t>Dev split, 40 scenarios, keyless provider. Held-out split reserved for one run after feature freeze.</a:t>
+              <a:t>Table: dev split, 40 scenarios, keyless provider. Right card: the same split on a real model. Held-out split reserved for one run.</a:t>
             </a:r>
           </a:p>
         </p:txBody>
@@ -21423,7 +21423,7 @@
                 </a:solidFill>
                 <a:latin typeface="Arial"/>
               </a:rPr>
-              <a:t>Sharpest ablation — A2, fusion</a:t>
+              <a:t>Real model — gemini-3.5-flash-lite, 26 Sep 2026</a:t>
             </a:r>
           </a:p>
           <a:p>
@@ -21442,7 +21442,7 @@
                 </a:solidFill>
                 <a:latin typeface="Calibri"/>
               </a:rPr>
-              <a:t>recall@k is identical at 0.960 with plain RRF, so every gold chunk was retrieved either way. Coverage still falls 0.772 → 0.718. That is sub-intent starvation, and no standard metric can see it.</a:t>
+              <a:t>Ripple vs static RAG, all 40 dev scenarios: 158/158 claims backed by their cited passage · 0 fabricated · recall 0.942 vs 0.835 · 1.44× tokens per turn · first answer −3.17 s on two-question calls.</a:t>
             </a:r>
           </a:p>
         </p:txBody>
@@ -21523,7 +21523,7 @@
                 </a:solidFill>
                 <a:latin typeface="Calibri"/>
               </a:rPr>
-              <a:t>Groundedness of 1.000 is an artefact of the keyless provider, which answers by copying the sentence it cites — the real number needs a model run.  ·  The keyless path cannot abstain on near-miss holes; two lexical heuristics were measured and discarded.  ·  Selection, not retrieval, is the bottleneck: 0.960 recall against 0.772 coverage.</a:t>
+              <a:t>The table's −1.036 s assumes an instant model; with ~2 s real replies the median is +1.80 s (static RAG +2.07 s) and the p90 tail is worse (10.1 s vs 2.5 s).  ·  With a real model static RAG edges coverage (0.854 vs 0.833).  ·  Grounding is an automated check, not human review.  ·  No currency cost: no published price configured.</a:t>
             </a:r>
           </a:p>
         </p:txBody>
@@ -21743,7 +21743,7 @@
                 </a:solidFill>
                 <a:latin typeface="Calibri"/>
               </a:rPr>
-              <a:t>The measured bottleneck is selection: recall 0.960, coverage 0.772. Our lexical reranker shared the retriever's bias and made it worse. A cross-encoder scores relevance rather than term overlap — the highest-value next experiment, and currently unmeasured.</a:t>
+              <a:t>The measured bottleneck is selection: recall 0.960, coverage 0.772 (keyless). Our lexical reranker shared the retriever's bias and made it worse. A cross-encoder scores relevance rather than term overlap — the highest-value next experiment, and currently unmeasured.</a:t>
             </a:r>
           </a:p>
         </p:txBody>

</xml_diff>